<commit_message>
comment csv creation file and update presentation individuelle
</commit_message>
<xml_diff>
--- a/Projet_presentation_individuelle.pptx
+++ b/Projet_presentation_individuelle.pptx
@@ -173,7 +173,9 @@
 <file path=ppt/revisionInfo.xml><?xml version="1.0" encoding="utf-8"?>
 <p1510:revInfo xmlns:a="http://schemas.openxmlformats.org/drawingml/2006/main" xmlns:r="http://schemas.openxmlformats.org/officeDocument/2006/relationships" xmlns:p1510="http://schemas.microsoft.com/office/powerpoint/2015/10/main">
   <p1510:revLst>
-    <p1510:client id="{16881204-1834-43EC-BC85-FBED33FD4DAB}" v="2" dt="2025-11-25T13:23:03.192"/>
+    <p1510:client id="{16881204-1834-43EC-BC85-FBED33FD4DAB}" v="6" dt="2025-11-28T07:30:35.484"/>
+    <p1510:client id="{4A1A1ABC-BCE8-48B7-B7DB-34700A7BB41D}" v="12" dt="2025-11-27T13:24:10.042"/>
+    <p1510:client id="{87C3BB84-BD66-DCF3-B304-11183336E11F}" v="1" dt="2025-11-28T07:23:58.260"/>
   </p1510:revLst>
 </p1510:revInfo>
 </file>
@@ -181,14 +183,30 @@
 <file path=ppt/changesInfos/changesInfo1.xml><?xml version="1.0" encoding="utf-8"?>
 <pc:chgInfo xmlns:a="http://schemas.openxmlformats.org/drawingml/2006/main" xmlns:r="http://schemas.openxmlformats.org/officeDocument/2006/relationships" xmlns:ac="http://schemas.microsoft.com/office/drawing/2013/main/command" xmlns:pc="http://schemas.microsoft.com/office/powerpoint/2013/main/command">
   <pc:docChgLst>
+    <pc:chgData name="Henry Lucas" userId="S::lucas.henry1@hes-so.ch::f42f6d5e-dd0c-45d0-8855-7a7b6c4b0d3e" providerId="AD" clId="Web-{87C3BB84-BD66-DCF3-B304-11183336E11F}"/>
+    <pc:docChg chg="sldOrd">
+      <pc:chgData name="Henry Lucas" userId="S::lucas.henry1@hes-so.ch::f42f6d5e-dd0c-45d0-8855-7a7b6c4b0d3e" providerId="AD" clId="Web-{87C3BB84-BD66-DCF3-B304-11183336E11F}" dt="2025-11-28T07:23:58.260" v="0"/>
+      <pc:docMkLst>
+        <pc:docMk/>
+      </pc:docMkLst>
+      <pc:sldChg chg="ord">
+        <pc:chgData name="Henry Lucas" userId="S::lucas.henry1@hes-so.ch::f42f6d5e-dd0c-45d0-8855-7a7b6c4b0d3e" providerId="AD" clId="Web-{87C3BB84-BD66-DCF3-B304-11183336E11F}" dt="2025-11-28T07:23:58.260" v="0"/>
+        <pc:sldMkLst>
+          <pc:docMk/>
+          <pc:sldMk cId="3845443206" sldId="814"/>
+        </pc:sldMkLst>
+      </pc:sldChg>
+    </pc:docChg>
+  </pc:docChgLst>
+  <pc:docChgLst>
     <pc:chgData name="Zanad Maroua" userId="3c8c1996-05ae-44ec-be8b-279f65d1a65a" providerId="ADAL" clId="{C4A395A7-2EF0-4F9E-8DE1-68D41C3A6BA2}"/>
-    <pc:docChg chg="modSld">
-      <pc:chgData name="Zanad Maroua" userId="3c8c1996-05ae-44ec-be8b-279f65d1a65a" providerId="ADAL" clId="{C4A395A7-2EF0-4F9E-8DE1-68D41C3A6BA2}" dt="2025-11-25T13:23:51.153" v="55" actId="20577"/>
+    <pc:docChg chg="delSld modSld modSection">
+      <pc:chgData name="Zanad Maroua" userId="3c8c1996-05ae-44ec-be8b-279f65d1a65a" providerId="ADAL" clId="{C4A395A7-2EF0-4F9E-8DE1-68D41C3A6BA2}" dt="2025-11-28T07:30:35.484" v="65" actId="20577"/>
       <pc:docMkLst>
         <pc:docMk/>
       </pc:docMkLst>
       <pc:sldChg chg="modSp mod">
-        <pc:chgData name="Zanad Maroua" userId="3c8c1996-05ae-44ec-be8b-279f65d1a65a" providerId="ADAL" clId="{C4A395A7-2EF0-4F9E-8DE1-68D41C3A6BA2}" dt="2025-11-25T13:23:51.153" v="55" actId="20577"/>
+        <pc:chgData name="Zanad Maroua" userId="3c8c1996-05ae-44ec-be8b-279f65d1a65a" providerId="ADAL" clId="{C4A395A7-2EF0-4F9E-8DE1-68D41C3A6BA2}" dt="2025-11-28T07:29:00.957" v="64" actId="114"/>
         <pc:sldMkLst>
           <pc:docMk/>
           <pc:sldMk cId="119865947" sldId="773"/>
@@ -202,13 +220,150 @@
           </ac:spMkLst>
         </pc:spChg>
         <pc:spChg chg="mod">
-          <ac:chgData name="Zanad Maroua" userId="3c8c1996-05ae-44ec-be8b-279f65d1a65a" providerId="ADAL" clId="{C4A395A7-2EF0-4F9E-8DE1-68D41C3A6BA2}" dt="2025-11-25T13:23:51.153" v="55" actId="20577"/>
+          <ac:chgData name="Zanad Maroua" userId="3c8c1996-05ae-44ec-be8b-279f65d1a65a" providerId="ADAL" clId="{C4A395A7-2EF0-4F9E-8DE1-68D41C3A6BA2}" dt="2025-11-28T07:29:00.957" v="64" actId="114"/>
           <ac:spMkLst>
             <pc:docMk/>
             <pc:sldMk cId="119865947" sldId="773"/>
             <ac:spMk id="3" creationId="{4A999ABB-7846-8388-8605-9AF93B146BDA}"/>
           </ac:spMkLst>
         </pc:spChg>
+      </pc:sldChg>
+      <pc:sldChg chg="modSp mod">
+        <pc:chgData name="Zanad Maroua" userId="3c8c1996-05ae-44ec-be8b-279f65d1a65a" providerId="ADAL" clId="{C4A395A7-2EF0-4F9E-8DE1-68D41C3A6BA2}" dt="2025-11-28T07:30:35.484" v="65" actId="20577"/>
+        <pc:sldMkLst>
+          <pc:docMk/>
+          <pc:sldMk cId="2637716327" sldId="811"/>
+        </pc:sldMkLst>
+        <pc:spChg chg="mod">
+          <ac:chgData name="Zanad Maroua" userId="3c8c1996-05ae-44ec-be8b-279f65d1a65a" providerId="ADAL" clId="{C4A395A7-2EF0-4F9E-8DE1-68D41C3A6BA2}" dt="2025-11-28T07:30:35.484" v="65" actId="20577"/>
+          <ac:spMkLst>
+            <pc:docMk/>
+            <pc:sldMk cId="2637716327" sldId="811"/>
+            <ac:spMk id="2" creationId="{D2D5B988-C23F-CA48-9881-12F56D4BFF45}"/>
+          </ac:spMkLst>
+        </pc:spChg>
+        <pc:spChg chg="mod">
+          <ac:chgData name="Zanad Maroua" userId="3c8c1996-05ae-44ec-be8b-279f65d1a65a" providerId="ADAL" clId="{C4A395A7-2EF0-4F9E-8DE1-68D41C3A6BA2}" dt="2025-11-27T09:28:56.104" v="59" actId="20577"/>
+          <ac:spMkLst>
+            <pc:docMk/>
+            <pc:sldMk cId="2637716327" sldId="811"/>
+            <ac:spMk id="3" creationId="{3B001909-4B88-F51A-76B3-9D2C5828DD9D}"/>
+          </ac:spMkLst>
+        </pc:spChg>
+      </pc:sldChg>
+      <pc:sldChg chg="del">
+        <pc:chgData name="Zanad Maroua" userId="3c8c1996-05ae-44ec-be8b-279f65d1a65a" providerId="ADAL" clId="{C4A395A7-2EF0-4F9E-8DE1-68D41C3A6BA2}" dt="2025-11-28T07:28:45.293" v="60" actId="2696"/>
+        <pc:sldMkLst>
+          <pc:docMk/>
+          <pc:sldMk cId="3845443206" sldId="814"/>
+        </pc:sldMkLst>
+      </pc:sldChg>
+      <pc:sldChg chg="del">
+        <pc:chgData name="Zanad Maroua" userId="3c8c1996-05ae-44ec-be8b-279f65d1a65a" providerId="ADAL" clId="{C4A395A7-2EF0-4F9E-8DE1-68D41C3A6BA2}" dt="2025-11-28T07:28:47.393" v="61" actId="2696"/>
+        <pc:sldMkLst>
+          <pc:docMk/>
+          <pc:sldMk cId="775291530" sldId="815"/>
+        </pc:sldMkLst>
+      </pc:sldChg>
+    </pc:docChg>
+  </pc:docChgLst>
+  <pc:docChgLst>
+    <pc:chgData name="Zanad Maroua" userId="3c8c1996-05ae-44ec-be8b-279f65d1a65a" providerId="ADAL" clId="{C5D2A7CB-567F-4B8E-9FC7-57D1CB8BF56D}"/>
+    <pc:docChg chg="undo custSel addSld modSld modSection">
+      <pc:chgData name="Zanad Maroua" userId="3c8c1996-05ae-44ec-be8b-279f65d1a65a" providerId="ADAL" clId="{C5D2A7CB-567F-4B8E-9FC7-57D1CB8BF56D}" dt="2025-11-27T13:24:52.886" v="1434" actId="20577"/>
+      <pc:docMkLst>
+        <pc:docMk/>
+      </pc:docMkLst>
+      <pc:sldChg chg="modSp mod">
+        <pc:chgData name="Zanad Maroua" userId="3c8c1996-05ae-44ec-be8b-279f65d1a65a" providerId="ADAL" clId="{C5D2A7CB-567F-4B8E-9FC7-57D1CB8BF56D}" dt="2025-11-27T13:16:12.780" v="514" actId="20577"/>
+        <pc:sldMkLst>
+          <pc:docMk/>
+          <pc:sldMk cId="2637716327" sldId="811"/>
+        </pc:sldMkLst>
+        <pc:spChg chg="mod">
+          <ac:chgData name="Zanad Maroua" userId="3c8c1996-05ae-44ec-be8b-279f65d1a65a" providerId="ADAL" clId="{C5D2A7CB-567F-4B8E-9FC7-57D1CB8BF56D}" dt="2025-11-27T13:16:12.780" v="514" actId="20577"/>
+          <ac:spMkLst>
+            <pc:docMk/>
+            <pc:sldMk cId="2637716327" sldId="811"/>
+            <ac:spMk id="3" creationId="{3B001909-4B88-F51A-76B3-9D2C5828DD9D}"/>
+          </ac:spMkLst>
+        </pc:spChg>
+      </pc:sldChg>
+      <pc:sldChg chg="modSp mod">
+        <pc:chgData name="Zanad Maroua" userId="3c8c1996-05ae-44ec-be8b-279f65d1a65a" providerId="ADAL" clId="{C5D2A7CB-567F-4B8E-9FC7-57D1CB8BF56D}" dt="2025-11-27T13:20:28.372" v="1132" actId="20577"/>
+        <pc:sldMkLst>
+          <pc:docMk/>
+          <pc:sldMk cId="1836895627" sldId="812"/>
+        </pc:sldMkLst>
+        <pc:spChg chg="mod">
+          <ac:chgData name="Zanad Maroua" userId="3c8c1996-05ae-44ec-be8b-279f65d1a65a" providerId="ADAL" clId="{C5D2A7CB-567F-4B8E-9FC7-57D1CB8BF56D}" dt="2025-11-27T13:20:28.372" v="1132" actId="20577"/>
+          <ac:spMkLst>
+            <pc:docMk/>
+            <pc:sldMk cId="1836895627" sldId="812"/>
+            <ac:spMk id="3" creationId="{943F6B2C-4A1E-ECD3-1D83-18D8C81E6C1F}"/>
+          </ac:spMkLst>
+        </pc:spChg>
+      </pc:sldChg>
+      <pc:sldChg chg="addSp modSp mod">
+        <pc:chgData name="Zanad Maroua" userId="3c8c1996-05ae-44ec-be8b-279f65d1a65a" providerId="ADAL" clId="{C5D2A7CB-567F-4B8E-9FC7-57D1CB8BF56D}" dt="2025-11-27T13:24:52.886" v="1434" actId="20577"/>
+        <pc:sldMkLst>
+          <pc:docMk/>
+          <pc:sldMk cId="701930509" sldId="813"/>
+        </pc:sldMkLst>
+        <pc:spChg chg="mod">
+          <ac:chgData name="Zanad Maroua" userId="3c8c1996-05ae-44ec-be8b-279f65d1a65a" providerId="ADAL" clId="{C5D2A7CB-567F-4B8E-9FC7-57D1CB8BF56D}" dt="2025-11-27T13:21:03.343" v="1140" actId="20577"/>
+          <ac:spMkLst>
+            <pc:docMk/>
+            <pc:sldMk cId="701930509" sldId="813"/>
+            <ac:spMk id="2" creationId="{1D5C19ED-14BA-9CE2-8784-047386E47952}"/>
+          </ac:spMkLst>
+        </pc:spChg>
+        <pc:spChg chg="mod">
+          <ac:chgData name="Zanad Maroua" userId="3c8c1996-05ae-44ec-be8b-279f65d1a65a" providerId="ADAL" clId="{C5D2A7CB-567F-4B8E-9FC7-57D1CB8BF56D}" dt="2025-11-27T13:24:52.886" v="1434" actId="20577"/>
+          <ac:spMkLst>
+            <pc:docMk/>
+            <pc:sldMk cId="701930509" sldId="813"/>
+            <ac:spMk id="3" creationId="{9C692B49-69B3-F49F-629D-8D67CB531E1C}"/>
+          </ac:spMkLst>
+        </pc:spChg>
+        <pc:spChg chg="add">
+          <ac:chgData name="Zanad Maroua" userId="3c8c1996-05ae-44ec-be8b-279f65d1a65a" providerId="ADAL" clId="{C5D2A7CB-567F-4B8E-9FC7-57D1CB8BF56D}" dt="2025-11-27T13:23:26.569" v="1373"/>
+          <ac:spMkLst>
+            <pc:docMk/>
+            <pc:sldMk cId="701930509" sldId="813"/>
+            <ac:spMk id="5" creationId="{EA17D0A8-7069-F868-74E7-314D3083B8D9}"/>
+          </ac:spMkLst>
+        </pc:spChg>
+        <pc:spChg chg="add mod">
+          <ac:chgData name="Zanad Maroua" userId="3c8c1996-05ae-44ec-be8b-279f65d1a65a" providerId="ADAL" clId="{C5D2A7CB-567F-4B8E-9FC7-57D1CB8BF56D}" dt="2025-11-27T13:23:53.883" v="1378" actId="14100"/>
+          <ac:spMkLst>
+            <pc:docMk/>
+            <pc:sldMk cId="701930509" sldId="813"/>
+            <ac:spMk id="6" creationId="{C134DB9B-B046-295F-1DB5-06F9C61A11D7}"/>
+          </ac:spMkLst>
+        </pc:spChg>
+        <pc:picChg chg="add mod">
+          <ac:chgData name="Zanad Maroua" userId="3c8c1996-05ae-44ec-be8b-279f65d1a65a" providerId="ADAL" clId="{C5D2A7CB-567F-4B8E-9FC7-57D1CB8BF56D}" dt="2025-11-27T13:24:19.605" v="1386" actId="14100"/>
+          <ac:picMkLst>
+            <pc:docMk/>
+            <pc:sldMk cId="701930509" sldId="813"/>
+            <ac:picMk id="9" creationId="{8EC1AF7C-75A4-C1A5-5AA5-C42728D92190}"/>
+          </ac:picMkLst>
+        </pc:picChg>
+      </pc:sldChg>
+      <pc:sldChg chg="add">
+        <pc:chgData name="Zanad Maroua" userId="3c8c1996-05ae-44ec-be8b-279f65d1a65a" providerId="ADAL" clId="{C5D2A7CB-567F-4B8E-9FC7-57D1CB8BF56D}" dt="2025-11-27T13:20:49.899" v="1133" actId="2890"/>
+        <pc:sldMkLst>
+          <pc:docMk/>
+          <pc:sldMk cId="3845443206" sldId="814"/>
+        </pc:sldMkLst>
+      </pc:sldChg>
+      <pc:sldChg chg="add">
+        <pc:chgData name="Zanad Maroua" userId="3c8c1996-05ae-44ec-be8b-279f65d1a65a" providerId="ADAL" clId="{C5D2A7CB-567F-4B8E-9FC7-57D1CB8BF56D}" dt="2025-11-27T13:20:53.529" v="1134" actId="2890"/>
+        <pc:sldMkLst>
+          <pc:docMk/>
+          <pc:sldMk cId="775291530" sldId="815"/>
+        </pc:sldMkLst>
       </pc:sldChg>
     </pc:docChg>
   </pc:docChgLst>
@@ -298,7 +453,7 @@
             <a:fld id="{A9A38115-2533-4DD5-A77A-754771AFE5B4}" type="datetimeFigureOut">
               <a:rPr lang="fr-FR" smtClean="0"/>
               <a:pPr/>
-              <a:t>25/11/2025</a:t>
+              <a:t>27/11/2025</a:t>
             </a:fld>
             <a:endParaRPr lang="fr-CH"/>
           </a:p>
@@ -465,7 +620,7 @@
             <a:fld id="{935D434A-8A59-4F13-9A59-26B08A6D282A}" type="datetimeFigureOut">
               <a:rPr lang="fr-FR" smtClean="0"/>
               <a:pPr/>
-              <a:t>25/11/2025</a:t>
+              <a:t>27/11/2025</a:t>
             </a:fld>
             <a:endParaRPr lang="fr-CH"/>
           </a:p>
@@ -789,7 +944,7 @@
               <a:buFontTx/>
               <a:buNone/>
             </a:pPr>
-            <a:endParaRPr lang="fr-CH" sz="800" dirty="0"/>
+            <a:endParaRPr lang="fr-CH" sz="800"/>
           </a:p>
         </p:txBody>
       </p:sp>
@@ -897,7 +1052,7 @@
           <a:bodyPr/>
           <a:lstStyle/>
           <a:p>
-            <a:endParaRPr lang="fr-CH" dirty="0"/>
+            <a:endParaRPr lang="fr-CH"/>
           </a:p>
         </p:txBody>
       </p:sp>
@@ -1011,7 +1166,7 @@
           <a:bodyPr/>
           <a:lstStyle/>
           <a:p>
-            <a:endParaRPr lang="fr-CH" dirty="0"/>
+            <a:endParaRPr lang="fr-CH"/>
           </a:p>
         </p:txBody>
       </p:sp>
@@ -1125,7 +1280,7 @@
           <a:bodyPr/>
           <a:lstStyle/>
           <a:p>
-            <a:endParaRPr lang="fr-CH" dirty="0"/>
+            <a:endParaRPr lang="fr-CH"/>
           </a:p>
         </p:txBody>
       </p:sp>
@@ -1229,18 +1384,18 @@
           <a:p>
             <a:pPr lvl="0"/>
             <a:r>
-              <a:rPr lang="fr-FR" dirty="0" err="1"/>
+              <a:rPr lang="fr-FR" err="1"/>
               <a:t>Demo</a:t>
             </a:r>
             <a:r>
-              <a:rPr lang="fr-FR" dirty="0"/>
+              <a:rPr lang="fr-FR"/>
               <a:t> </a:t>
             </a:r>
             <a:r>
-              <a:rPr lang="fr-FR" dirty="0" err="1"/>
+              <a:rPr lang="fr-FR" err="1"/>
               <a:t>text</a:t>
             </a:r>
-            <a:endParaRPr lang="fr-CH" dirty="0"/>
+            <a:endParaRPr lang="fr-CH"/>
           </a:p>
         </p:txBody>
       </p:sp>
@@ -1324,7 +1479,7 @@
               </a:rPr>
               <a:t>Dr P.-A. Mudry</a:t>
             </a:r>
-            <a:endParaRPr kumimoji="0" lang="fr-CH" sz="1000" b="0" i="0" u="none" strike="noStrike" kern="1200" cap="none" spc="0" normalizeH="0" baseline="0" noProof="0" dirty="0">
+            <a:endParaRPr kumimoji="0" lang="fr-CH" sz="1000" b="0" i="0" u="none" strike="noStrike" kern="1200" cap="none" spc="0" normalizeH="0" baseline="0" noProof="0">
               <a:ln>
                 <a:noFill/>
               </a:ln>
@@ -1424,23 +1579,6 @@
               </a:rPr>
               <a:t>1. Demo course</a:t>
             </a:r>
-            <a:endParaRPr kumimoji="0" lang="fr-FR" sz="1000" b="0" i="0" u="none" strike="noStrike" kern="1200" cap="none" spc="0" normalizeH="0" baseline="0" noProof="0" dirty="0">
-              <a:ln>
-                <a:noFill/>
-              </a:ln>
-              <a:solidFill>
-                <a:prstClr val="black">
-                  <a:lumMod val="65000"/>
-                  <a:lumOff val="35000"/>
-                </a:prstClr>
-              </a:solidFill>
-              <a:effectLst/>
-              <a:uLnTx/>
-              <a:uFillTx/>
-              <a:latin typeface="Open Sans Light" panose="020B0306030504020204" pitchFamily="34" charset="0"/>
-              <a:ea typeface="Open Sans Light" panose="020B0306030504020204" pitchFamily="34" charset="0"/>
-              <a:cs typeface="Open Sans Light" panose="020B0306030504020204" pitchFamily="34" charset="0"/>
-            </a:endParaRPr>
           </a:p>
         </p:txBody>
       </p:sp>
@@ -2284,7 +2422,7 @@
               </a:rPr>
               <a:t>Dr P.-A. Mudry</a:t>
             </a:r>
-            <a:endParaRPr kumimoji="0" lang="fr-CH" sz="1000" b="0" i="0" u="none" strike="noStrike" kern="1200" cap="none" spc="0" normalizeH="0" baseline="0" noProof="0" dirty="0">
+            <a:endParaRPr kumimoji="0" lang="fr-CH" sz="1000" b="0" i="0" u="none" strike="noStrike" kern="1200" cap="none" spc="0" normalizeH="0" baseline="0" noProof="0">
               <a:ln>
                 <a:noFill/>
               </a:ln>
@@ -2384,23 +2522,6 @@
               </a:rPr>
               <a:t>1. Demo course</a:t>
             </a:r>
-            <a:endParaRPr kumimoji="0" lang="fr-FR" sz="1000" b="0" i="0" u="none" strike="noStrike" kern="1200" cap="none" spc="0" normalizeH="0" baseline="0" noProof="0" dirty="0">
-              <a:ln>
-                <a:noFill/>
-              </a:ln>
-              <a:solidFill>
-                <a:prstClr val="black">
-                  <a:lumMod val="65000"/>
-                  <a:lumOff val="35000"/>
-                </a:prstClr>
-              </a:solidFill>
-              <a:effectLst/>
-              <a:uLnTx/>
-              <a:uFillTx/>
-              <a:latin typeface="Open Sans Light" panose="020B0306030504020204" pitchFamily="34" charset="0"/>
-              <a:ea typeface="Open Sans Light" panose="020B0306030504020204" pitchFamily="34" charset="0"/>
-              <a:cs typeface="Open Sans Light" panose="020B0306030504020204" pitchFamily="34" charset="0"/>
-            </a:endParaRPr>
           </a:p>
         </p:txBody>
       </p:sp>
@@ -2709,7 +2830,7 @@
               </a:rPr>
               <a:t>Dr P.-A. Mudry</a:t>
             </a:r>
-            <a:endParaRPr kumimoji="0" lang="fr-CH" sz="1000" b="0" i="0" u="none" strike="noStrike" kern="1200" cap="none" spc="0" normalizeH="0" baseline="0" noProof="0" dirty="0">
+            <a:endParaRPr kumimoji="0" lang="fr-CH" sz="1000" b="0" i="0" u="none" strike="noStrike" kern="1200" cap="none" spc="0" normalizeH="0" baseline="0" noProof="0">
               <a:ln>
                 <a:noFill/>
               </a:ln>
@@ -2809,23 +2930,6 @@
               </a:rPr>
               <a:t>1. Demo course</a:t>
             </a:r>
-            <a:endParaRPr kumimoji="0" lang="fr-FR" sz="1000" b="0" i="0" u="none" strike="noStrike" kern="1200" cap="none" spc="0" normalizeH="0" baseline="0" noProof="0" dirty="0">
-              <a:ln>
-                <a:noFill/>
-              </a:ln>
-              <a:solidFill>
-                <a:prstClr val="black">
-                  <a:lumMod val="65000"/>
-                  <a:lumOff val="35000"/>
-                </a:prstClr>
-              </a:solidFill>
-              <a:effectLst/>
-              <a:uLnTx/>
-              <a:uFillTx/>
-              <a:latin typeface="Open Sans Light" panose="020B0306030504020204" pitchFamily="34" charset="0"/>
-              <a:ea typeface="Open Sans Light" panose="020B0306030504020204" pitchFamily="34" charset="0"/>
-              <a:cs typeface="Open Sans Light" panose="020B0306030504020204" pitchFamily="34" charset="0"/>
-            </a:endParaRPr>
           </a:p>
         </p:txBody>
       </p:sp>
@@ -3144,7 +3248,7 @@
               </a:rPr>
               <a:t>Dr P.-A. Mudry</a:t>
             </a:r>
-            <a:endParaRPr kumimoji="0" lang="fr-CH" sz="1000" b="0" i="0" u="none" strike="noStrike" kern="1200" cap="none" spc="0" normalizeH="0" baseline="0" noProof="0" dirty="0">
+            <a:endParaRPr kumimoji="0" lang="fr-CH" sz="1000" b="0" i="0" u="none" strike="noStrike" kern="1200" cap="none" spc="0" normalizeH="0" baseline="0" noProof="0">
               <a:ln>
                 <a:noFill/>
               </a:ln>
@@ -3244,23 +3348,6 @@
               </a:rPr>
               <a:t>1. Demo course</a:t>
             </a:r>
-            <a:endParaRPr kumimoji="0" lang="fr-FR" sz="1000" b="0" i="0" u="none" strike="noStrike" kern="1200" cap="none" spc="0" normalizeH="0" baseline="0" noProof="0" dirty="0">
-              <a:ln>
-                <a:noFill/>
-              </a:ln>
-              <a:solidFill>
-                <a:prstClr val="black">
-                  <a:lumMod val="65000"/>
-                  <a:lumOff val="35000"/>
-                </a:prstClr>
-              </a:solidFill>
-              <a:effectLst/>
-              <a:uLnTx/>
-              <a:uFillTx/>
-              <a:latin typeface="Open Sans Light" panose="020B0306030504020204" pitchFamily="34" charset="0"/>
-              <a:ea typeface="Open Sans Light" panose="020B0306030504020204" pitchFamily="34" charset="0"/>
-              <a:cs typeface="Open Sans Light" panose="020B0306030504020204" pitchFamily="34" charset="0"/>
-            </a:endParaRPr>
           </a:p>
         </p:txBody>
       </p:sp>
@@ -3522,7 +3609,7 @@
               </a:rPr>
               <a:t>Dr P.-A. Mudry</a:t>
             </a:r>
-            <a:endParaRPr kumimoji="0" lang="fr-CH" sz="1000" b="0" i="0" u="none" strike="noStrike" kern="1200" cap="none" spc="0" normalizeH="0" baseline="0" noProof="0" dirty="0">
+            <a:endParaRPr kumimoji="0" lang="fr-CH" sz="1000" b="0" i="0" u="none" strike="noStrike" kern="1200" cap="none" spc="0" normalizeH="0" baseline="0" noProof="0">
               <a:ln>
                 <a:noFill/>
               </a:ln>
@@ -3622,23 +3709,6 @@
               </a:rPr>
               <a:t>1. Demo course</a:t>
             </a:r>
-            <a:endParaRPr kumimoji="0" lang="fr-FR" sz="1000" b="0" i="0" u="none" strike="noStrike" kern="1200" cap="none" spc="0" normalizeH="0" baseline="0" noProof="0" dirty="0">
-              <a:ln>
-                <a:noFill/>
-              </a:ln>
-              <a:solidFill>
-                <a:prstClr val="black">
-                  <a:lumMod val="65000"/>
-                  <a:lumOff val="35000"/>
-                </a:prstClr>
-              </a:solidFill>
-              <a:effectLst/>
-              <a:uLnTx/>
-              <a:uFillTx/>
-              <a:latin typeface="Open Sans Light" panose="020B0306030504020204" pitchFamily="34" charset="0"/>
-              <a:ea typeface="Open Sans Light" panose="020B0306030504020204" pitchFamily="34" charset="0"/>
-              <a:cs typeface="Open Sans Light" panose="020B0306030504020204" pitchFamily="34" charset="0"/>
-            </a:endParaRPr>
           </a:p>
         </p:txBody>
       </p:sp>
@@ -3821,7 +3891,7 @@
               <a:rPr lang="fr-FR"/>
               <a:t>Modifiez le style du titre</a:t>
             </a:r>
-            <a:endParaRPr lang="fr-CH" dirty="0"/>
+            <a:endParaRPr lang="fr-CH"/>
           </a:p>
         </p:txBody>
       </p:sp>
@@ -3878,7 +3948,7 @@
               <a:rPr lang="fr-FR"/>
               <a:t>Cinquième niveau</a:t>
             </a:r>
-            <a:endParaRPr lang="fr-CH" dirty="0"/>
+            <a:endParaRPr lang="fr-CH"/>
           </a:p>
         </p:txBody>
       </p:sp>
@@ -3961,7 +4031,7 @@
               </a:tabLst>
               <a:defRPr/>
             </a:pPr>
-            <a:endParaRPr kumimoji="0" lang="fr-CH" sz="2000" b="1" i="0" u="none" strike="noStrike" kern="1200" cap="none" spc="0" normalizeH="0" baseline="0" noProof="0" dirty="0" err="1">
+            <a:endParaRPr kumimoji="0" lang="fr-CH" sz="2000" b="1" i="0" u="none" strike="noStrike" kern="1200" cap="none" spc="0" normalizeH="0" baseline="0" noProof="0" err="1">
               <a:ln>
                 <a:noFill/>
               </a:ln>
@@ -4058,7 +4128,7 @@
               </a:rPr>
               <a:t>Dr P.-A. Mudry</a:t>
             </a:r>
-            <a:endParaRPr kumimoji="0" lang="fr-CH" sz="1000" b="0" i="0" u="none" strike="noStrike" kern="1200" cap="none" spc="0" normalizeH="0" baseline="0" noProof="0" dirty="0">
+            <a:endParaRPr kumimoji="0" lang="fr-CH" sz="1000" b="0" i="0" u="none" strike="noStrike" kern="1200" cap="none" spc="0" normalizeH="0" baseline="0" noProof="0">
               <a:ln>
                 <a:noFill/>
               </a:ln>
@@ -4158,23 +4228,6 @@
               </a:rPr>
               <a:t>1. Demo course</a:t>
             </a:r>
-            <a:endParaRPr kumimoji="0" lang="fr-FR" sz="1000" b="0" i="0" u="none" strike="noStrike" kern="1200" cap="none" spc="0" normalizeH="0" baseline="0" noProof="0" dirty="0">
-              <a:ln>
-                <a:noFill/>
-              </a:ln>
-              <a:solidFill>
-                <a:prstClr val="black">
-                  <a:lumMod val="65000"/>
-                  <a:lumOff val="35000"/>
-                </a:prstClr>
-              </a:solidFill>
-              <a:effectLst/>
-              <a:uLnTx/>
-              <a:uFillTx/>
-              <a:latin typeface="Open Sans Light" panose="020B0306030504020204" pitchFamily="34" charset="0"/>
-              <a:ea typeface="Open Sans Light" panose="020B0306030504020204" pitchFamily="34" charset="0"/>
-              <a:cs typeface="Open Sans Light" panose="020B0306030504020204" pitchFamily="34" charset="0"/>
-            </a:endParaRPr>
           </a:p>
         </p:txBody>
       </p:sp>
@@ -4354,10 +4407,10 @@
           <a:lstStyle/>
           <a:p>
             <a:r>
-              <a:rPr lang="fr-FR" dirty="0"/>
+              <a:rPr lang="fr-FR"/>
               <a:t>Modifiez le style du titre</a:t>
             </a:r>
-            <a:endParaRPr lang="fr-CH" dirty="0"/>
+            <a:endParaRPr lang="fr-CH"/>
           </a:p>
         </p:txBody>
       </p:sp>
@@ -4383,38 +4436,38 @@
           <a:p>
             <a:pPr lvl="0"/>
             <a:r>
-              <a:rPr lang="fr-FR" dirty="0"/>
+              <a:rPr lang="fr-FR"/>
               <a:t>Modifiez les styles du texte du masque</a:t>
             </a:r>
           </a:p>
           <a:p>
             <a:pPr lvl="1"/>
             <a:r>
-              <a:rPr lang="fr-FR" dirty="0"/>
+              <a:rPr lang="fr-FR"/>
               <a:t>Deuxième niveau</a:t>
             </a:r>
           </a:p>
           <a:p>
             <a:pPr lvl="2"/>
             <a:r>
-              <a:rPr lang="fr-FR" dirty="0"/>
+              <a:rPr lang="fr-FR"/>
               <a:t>Troisième niveau</a:t>
             </a:r>
           </a:p>
           <a:p>
             <a:pPr lvl="3"/>
             <a:r>
-              <a:rPr lang="fr-FR" dirty="0"/>
+              <a:rPr lang="fr-FR"/>
               <a:t>Quatrième niveau</a:t>
             </a:r>
           </a:p>
           <a:p>
             <a:pPr lvl="4"/>
             <a:r>
-              <a:rPr lang="fr-FR" dirty="0"/>
+              <a:rPr lang="fr-FR"/>
               <a:t>Cinquième niveau</a:t>
             </a:r>
-            <a:endParaRPr lang="fr-CH" dirty="0"/>
+            <a:endParaRPr lang="fr-CH"/>
           </a:p>
         </p:txBody>
       </p:sp>
@@ -4498,7 +4551,7 @@
               </a:rPr>
               <a:t>Dr P.-A. Mudry</a:t>
             </a:r>
-            <a:endParaRPr kumimoji="0" lang="fr-CH" sz="1000" b="0" i="0" u="none" strike="noStrike" kern="1200" cap="none" spc="0" normalizeH="0" baseline="0" noProof="0" dirty="0">
+            <a:endParaRPr kumimoji="0" lang="fr-CH" sz="1000" b="0" i="0" u="none" strike="noStrike" kern="1200" cap="none" spc="0" normalizeH="0" baseline="0" noProof="0">
               <a:ln>
                 <a:noFill/>
               </a:ln>
@@ -4598,23 +4651,6 @@
               </a:rPr>
               <a:t>1. Demo course</a:t>
             </a:r>
-            <a:endParaRPr kumimoji="0" lang="fr-FR" sz="1000" b="0" i="0" u="none" strike="noStrike" kern="1200" cap="none" spc="0" normalizeH="0" baseline="0" noProof="0" dirty="0">
-              <a:ln>
-                <a:noFill/>
-              </a:ln>
-              <a:solidFill>
-                <a:prstClr val="black">
-                  <a:lumMod val="65000"/>
-                  <a:lumOff val="35000"/>
-                </a:prstClr>
-              </a:solidFill>
-              <a:effectLst/>
-              <a:uLnTx/>
-              <a:uFillTx/>
-              <a:latin typeface="Open Sans Light" panose="020B0306030504020204" pitchFamily="34" charset="0"/>
-              <a:ea typeface="Open Sans Light" panose="020B0306030504020204" pitchFamily="34" charset="0"/>
-              <a:cs typeface="Open Sans Light" panose="020B0306030504020204" pitchFamily="34" charset="0"/>
-            </a:endParaRPr>
           </a:p>
         </p:txBody>
       </p:sp>
@@ -4797,7 +4833,7 @@
               <a:rPr lang="fr-FR"/>
               <a:t>Modifiez le style du titre</a:t>
             </a:r>
-            <a:endParaRPr lang="fr-CH" dirty="0"/>
+            <a:endParaRPr lang="fr-CH"/>
           </a:p>
         </p:txBody>
       </p:sp>
@@ -4854,7 +4890,7 @@
               <a:rPr lang="fr-FR"/>
               <a:t>Cinquième niveau</a:t>
             </a:r>
-            <a:endParaRPr lang="fr-CH" dirty="0"/>
+            <a:endParaRPr lang="fr-CH"/>
           </a:p>
         </p:txBody>
       </p:sp>
@@ -4937,7 +4973,7 @@
               </a:tabLst>
               <a:defRPr/>
             </a:pPr>
-            <a:endParaRPr kumimoji="0" lang="fr-CH" sz="2000" b="1" i="0" u="none" strike="noStrike" kern="1200" cap="none" spc="0" normalizeH="0" baseline="0" noProof="0" dirty="0" err="1">
+            <a:endParaRPr kumimoji="0" lang="fr-CH" sz="2000" b="1" i="0" u="none" strike="noStrike" kern="1200" cap="none" spc="0" normalizeH="0" baseline="0" noProof="0" err="1">
               <a:ln>
                 <a:noFill/>
               </a:ln>
@@ -5034,7 +5070,7 @@
               </a:rPr>
               <a:t>Dr P.-A. Mudry</a:t>
             </a:r>
-            <a:endParaRPr kumimoji="0" lang="fr-CH" sz="1000" b="0" i="0" u="none" strike="noStrike" kern="1200" cap="none" spc="0" normalizeH="0" baseline="0" noProof="0" dirty="0">
+            <a:endParaRPr kumimoji="0" lang="fr-CH" sz="1000" b="0" i="0" u="none" strike="noStrike" kern="1200" cap="none" spc="0" normalizeH="0" baseline="0" noProof="0">
               <a:ln>
                 <a:noFill/>
               </a:ln>
@@ -5134,23 +5170,6 @@
               </a:rPr>
               <a:t>1. Demo course</a:t>
             </a:r>
-            <a:endParaRPr kumimoji="0" lang="fr-FR" sz="1000" b="0" i="0" u="none" strike="noStrike" kern="1200" cap="none" spc="0" normalizeH="0" baseline="0" noProof="0" dirty="0">
-              <a:ln>
-                <a:noFill/>
-              </a:ln>
-              <a:solidFill>
-                <a:prstClr val="black">
-                  <a:lumMod val="65000"/>
-                  <a:lumOff val="35000"/>
-                </a:prstClr>
-              </a:solidFill>
-              <a:effectLst/>
-              <a:uLnTx/>
-              <a:uFillTx/>
-              <a:latin typeface="Open Sans Light" panose="020B0306030504020204" pitchFamily="34" charset="0"/>
-              <a:ea typeface="Open Sans Light" panose="020B0306030504020204" pitchFamily="34" charset="0"/>
-              <a:cs typeface="Open Sans Light" panose="020B0306030504020204" pitchFamily="34" charset="0"/>
-            </a:endParaRPr>
           </a:p>
         </p:txBody>
       </p:sp>
@@ -5333,7 +5352,7 @@
               <a:rPr lang="fr-FR"/>
               <a:t>Modifiez le style du titre</a:t>
             </a:r>
-            <a:endParaRPr lang="fr-CH" dirty="0"/>
+            <a:endParaRPr lang="fr-CH"/>
           </a:p>
         </p:txBody>
       </p:sp>
@@ -5390,7 +5409,7 @@
               <a:rPr lang="fr-FR"/>
               <a:t>Cinquième niveau</a:t>
             </a:r>
-            <a:endParaRPr lang="fr-CH" dirty="0"/>
+            <a:endParaRPr lang="fr-CH"/>
           </a:p>
         </p:txBody>
       </p:sp>
@@ -5473,7 +5492,7 @@
               </a:tabLst>
               <a:defRPr/>
             </a:pPr>
-            <a:endParaRPr kumimoji="0" lang="fr-CH" sz="2000" b="1" i="0" u="none" strike="noStrike" kern="1200" cap="none" spc="0" normalizeH="0" baseline="0" noProof="0" dirty="0" err="1">
+            <a:endParaRPr kumimoji="0" lang="fr-CH" sz="2000" b="1" i="0" u="none" strike="noStrike" kern="1200" cap="none" spc="0" normalizeH="0" baseline="0" noProof="0" err="1">
               <a:ln>
                 <a:noFill/>
               </a:ln>
@@ -5570,7 +5589,7 @@
               </a:rPr>
               <a:t>Dr P.-A. Mudry</a:t>
             </a:r>
-            <a:endParaRPr kumimoji="0" lang="fr-CH" sz="1000" b="0" i="0" u="none" strike="noStrike" kern="1200" cap="none" spc="0" normalizeH="0" baseline="0" noProof="0" dirty="0">
+            <a:endParaRPr kumimoji="0" lang="fr-CH" sz="1000" b="0" i="0" u="none" strike="noStrike" kern="1200" cap="none" spc="0" normalizeH="0" baseline="0" noProof="0">
               <a:ln>
                 <a:noFill/>
               </a:ln>
@@ -5670,23 +5689,6 @@
               </a:rPr>
               <a:t>1. Demo course</a:t>
             </a:r>
-            <a:endParaRPr kumimoji="0" lang="fr-FR" sz="1000" b="0" i="0" u="none" strike="noStrike" kern="1200" cap="none" spc="0" normalizeH="0" baseline="0" noProof="0" dirty="0">
-              <a:ln>
-                <a:noFill/>
-              </a:ln>
-              <a:solidFill>
-                <a:prstClr val="black">
-                  <a:lumMod val="65000"/>
-                  <a:lumOff val="35000"/>
-                </a:prstClr>
-              </a:solidFill>
-              <a:effectLst/>
-              <a:uLnTx/>
-              <a:uFillTx/>
-              <a:latin typeface="Open Sans Light" panose="020B0306030504020204" pitchFamily="34" charset="0"/>
-              <a:ea typeface="Open Sans Light" panose="020B0306030504020204" pitchFamily="34" charset="0"/>
-              <a:cs typeface="Open Sans Light" panose="020B0306030504020204" pitchFamily="34" charset="0"/>
-            </a:endParaRPr>
           </a:p>
         </p:txBody>
       </p:sp>
@@ -5865,10 +5867,10 @@
           </a:lstStyle>
           <a:p>
             <a:r>
-              <a:rPr lang="fr-FR" dirty="0"/>
+              <a:rPr lang="fr-FR"/>
               <a:t>1. Modifiez le style du titre</a:t>
             </a:r>
-            <a:endParaRPr lang="fr-CH" dirty="0"/>
+            <a:endParaRPr lang="fr-CH"/>
           </a:p>
         </p:txBody>
       </p:sp>
@@ -6071,7 +6073,7 @@
               </a:rPr>
               <a:t>Dr P.-A. Mudry</a:t>
             </a:r>
-            <a:endParaRPr kumimoji="0" lang="fr-CH" sz="1000" b="0" i="0" u="none" strike="noStrike" kern="1200" cap="none" spc="0" normalizeH="0" baseline="0" noProof="0" dirty="0">
+            <a:endParaRPr kumimoji="0" lang="fr-CH" sz="1000" b="0" i="0" u="none" strike="noStrike" kern="1200" cap="none" spc="0" normalizeH="0" baseline="0" noProof="0">
               <a:ln>
                 <a:noFill/>
               </a:ln>
@@ -6171,23 +6173,6 @@
               </a:rPr>
               <a:t>1. Demo course</a:t>
             </a:r>
-            <a:endParaRPr kumimoji="0" lang="fr-FR" sz="1000" b="0" i="0" u="none" strike="noStrike" kern="1200" cap="none" spc="0" normalizeH="0" baseline="0" noProof="0" dirty="0">
-              <a:ln>
-                <a:noFill/>
-              </a:ln>
-              <a:solidFill>
-                <a:prstClr val="black">
-                  <a:lumMod val="65000"/>
-                  <a:lumOff val="35000"/>
-                </a:prstClr>
-              </a:solidFill>
-              <a:effectLst/>
-              <a:uLnTx/>
-              <a:uFillTx/>
-              <a:latin typeface="Open Sans Light" panose="020B0306030504020204" pitchFamily="34" charset="0"/>
-              <a:ea typeface="Open Sans Light" panose="020B0306030504020204" pitchFamily="34" charset="0"/>
-              <a:cs typeface="Open Sans Light" panose="020B0306030504020204" pitchFamily="34" charset="0"/>
-            </a:endParaRPr>
           </a:p>
         </p:txBody>
       </p:sp>
@@ -6414,38 +6399,38 @@
           <a:p>
             <a:pPr lvl="0"/>
             <a:r>
-              <a:rPr lang="fr-FR" dirty="0"/>
+              <a:rPr lang="fr-FR"/>
               <a:t>Modifiez les styles du texte du masque</a:t>
             </a:r>
           </a:p>
           <a:p>
             <a:pPr lvl="1"/>
             <a:r>
-              <a:rPr lang="fr-FR" dirty="0"/>
+              <a:rPr lang="fr-FR"/>
               <a:t>Deuxième niveau</a:t>
             </a:r>
           </a:p>
           <a:p>
             <a:pPr lvl="2"/>
             <a:r>
-              <a:rPr lang="fr-FR" dirty="0"/>
+              <a:rPr lang="fr-FR"/>
               <a:t>Troisième niveau</a:t>
             </a:r>
           </a:p>
           <a:p>
             <a:pPr lvl="3"/>
             <a:r>
-              <a:rPr lang="fr-FR" dirty="0"/>
+              <a:rPr lang="fr-FR"/>
               <a:t>Quatrième niveau</a:t>
             </a:r>
           </a:p>
           <a:p>
             <a:pPr lvl="4"/>
             <a:r>
-              <a:rPr lang="fr-FR" dirty="0"/>
+              <a:rPr lang="fr-FR"/>
               <a:t>Cinquième niveau</a:t>
             </a:r>
-            <a:endParaRPr lang="fr-CH" dirty="0"/>
+            <a:endParaRPr lang="fr-CH"/>
           </a:p>
         </p:txBody>
       </p:sp>
@@ -6614,7 +6599,7 @@
               </a:rPr>
               <a:t>Dr P.-A. Mudry</a:t>
             </a:r>
-            <a:endParaRPr kumimoji="0" lang="fr-CH" sz="1000" b="0" i="0" u="none" strike="noStrike" kern="1200" cap="none" spc="0" normalizeH="0" baseline="0" noProof="0" dirty="0">
+            <a:endParaRPr kumimoji="0" lang="fr-CH" sz="1000" b="0" i="0" u="none" strike="noStrike" kern="1200" cap="none" spc="0" normalizeH="0" baseline="0" noProof="0">
               <a:ln>
                 <a:noFill/>
               </a:ln>
@@ -6714,23 +6699,6 @@
               </a:rPr>
               <a:t>1. Demo course</a:t>
             </a:r>
-            <a:endParaRPr kumimoji="0" lang="fr-FR" sz="1000" b="0" i="0" u="none" strike="noStrike" kern="1200" cap="none" spc="0" normalizeH="0" baseline="0" noProof="0" dirty="0">
-              <a:ln>
-                <a:noFill/>
-              </a:ln>
-              <a:solidFill>
-                <a:prstClr val="black">
-                  <a:lumMod val="65000"/>
-                  <a:lumOff val="35000"/>
-                </a:prstClr>
-              </a:solidFill>
-              <a:effectLst/>
-              <a:uLnTx/>
-              <a:uFillTx/>
-              <a:latin typeface="Open Sans Light" panose="020B0306030504020204" pitchFamily="34" charset="0"/>
-              <a:ea typeface="Open Sans Light" panose="020B0306030504020204" pitchFamily="34" charset="0"/>
-              <a:cs typeface="Open Sans Light" panose="020B0306030504020204" pitchFamily="34" charset="0"/>
-            </a:endParaRPr>
           </a:p>
         </p:txBody>
       </p:sp>
@@ -7026,38 +6994,38 @@
           <a:p>
             <a:pPr lvl="0"/>
             <a:r>
-              <a:rPr lang="fr-FR" dirty="0"/>
+              <a:rPr lang="fr-FR"/>
               <a:t>Modifiez les styles du texte du masque</a:t>
             </a:r>
           </a:p>
           <a:p>
             <a:pPr lvl="1"/>
             <a:r>
-              <a:rPr lang="fr-FR" dirty="0"/>
+              <a:rPr lang="fr-FR"/>
               <a:t>Deuxième niveau</a:t>
             </a:r>
           </a:p>
           <a:p>
             <a:pPr lvl="2"/>
             <a:r>
-              <a:rPr lang="fr-FR" dirty="0"/>
+              <a:rPr lang="fr-FR"/>
               <a:t>Troisième niveau</a:t>
             </a:r>
           </a:p>
           <a:p>
             <a:pPr lvl="3"/>
             <a:r>
-              <a:rPr lang="fr-FR" dirty="0"/>
+              <a:rPr lang="fr-FR"/>
               <a:t>Quatrième niveau</a:t>
             </a:r>
           </a:p>
           <a:p>
             <a:pPr lvl="4"/>
             <a:r>
-              <a:rPr lang="fr-FR" dirty="0"/>
+              <a:rPr lang="fr-FR"/>
               <a:t>Cinquième niveau</a:t>
             </a:r>
-            <a:endParaRPr lang="fr-CH" dirty="0"/>
+            <a:endParaRPr lang="fr-CH"/>
           </a:p>
         </p:txBody>
       </p:sp>
@@ -7291,7 +7259,7 @@
               </a:rPr>
               <a:t>Dr P.-A. Mudry</a:t>
             </a:r>
-            <a:endParaRPr kumimoji="0" lang="fr-CH" sz="1000" b="0" i="0" u="none" strike="noStrike" kern="1200" cap="none" spc="0" normalizeH="0" baseline="0" noProof="0" dirty="0">
+            <a:endParaRPr kumimoji="0" lang="fr-CH" sz="1000" b="0" i="0" u="none" strike="noStrike" kern="1200" cap="none" spc="0" normalizeH="0" baseline="0" noProof="0">
               <a:ln>
                 <a:noFill/>
               </a:ln>
@@ -7391,23 +7359,6 @@
               </a:rPr>
               <a:t>1. Demo course</a:t>
             </a:r>
-            <a:endParaRPr kumimoji="0" lang="fr-FR" sz="1000" b="0" i="0" u="none" strike="noStrike" kern="1200" cap="none" spc="0" normalizeH="0" baseline="0" noProof="0" dirty="0">
-              <a:ln>
-                <a:noFill/>
-              </a:ln>
-              <a:solidFill>
-                <a:prstClr val="black">
-                  <a:lumMod val="65000"/>
-                  <a:lumOff val="35000"/>
-                </a:prstClr>
-              </a:solidFill>
-              <a:effectLst/>
-              <a:uLnTx/>
-              <a:uFillTx/>
-              <a:latin typeface="Open Sans Light" panose="020B0306030504020204" pitchFamily="34" charset="0"/>
-              <a:ea typeface="Open Sans Light" panose="020B0306030504020204" pitchFamily="34" charset="0"/>
-              <a:cs typeface="Open Sans Light" panose="020B0306030504020204" pitchFamily="34" charset="0"/>
-            </a:endParaRPr>
           </a:p>
         </p:txBody>
       </p:sp>
@@ -7669,7 +7620,7 @@
               </a:rPr>
               <a:t>Dr P.-A. Mudry</a:t>
             </a:r>
-            <a:endParaRPr kumimoji="0" lang="fr-CH" sz="1000" b="0" i="0" u="none" strike="noStrike" kern="1200" cap="none" spc="0" normalizeH="0" baseline="0" noProof="0" dirty="0">
+            <a:endParaRPr kumimoji="0" lang="fr-CH" sz="1000" b="0" i="0" u="none" strike="noStrike" kern="1200" cap="none" spc="0" normalizeH="0" baseline="0" noProof="0">
               <a:ln>
                 <a:noFill/>
               </a:ln>
@@ -7769,23 +7720,6 @@
               </a:rPr>
               <a:t>1. Demo course</a:t>
             </a:r>
-            <a:endParaRPr kumimoji="0" lang="fr-FR" sz="1000" b="0" i="0" u="none" strike="noStrike" kern="1200" cap="none" spc="0" normalizeH="0" baseline="0" noProof="0" dirty="0">
-              <a:ln>
-                <a:noFill/>
-              </a:ln>
-              <a:solidFill>
-                <a:prstClr val="black">
-                  <a:lumMod val="65000"/>
-                  <a:lumOff val="35000"/>
-                </a:prstClr>
-              </a:solidFill>
-              <a:effectLst/>
-              <a:uLnTx/>
-              <a:uFillTx/>
-              <a:latin typeface="Open Sans Light" panose="020B0306030504020204" pitchFamily="34" charset="0"/>
-              <a:ea typeface="Open Sans Light" panose="020B0306030504020204" pitchFamily="34" charset="0"/>
-              <a:cs typeface="Open Sans Light" panose="020B0306030504020204" pitchFamily="34" charset="0"/>
-            </a:endParaRPr>
           </a:p>
         </p:txBody>
       </p:sp>
@@ -8019,7 +7953,7 @@
               </a:rPr>
               <a:t>Dr P.-A. Mudry</a:t>
             </a:r>
-            <a:endParaRPr kumimoji="0" lang="fr-CH" sz="1000" b="0" i="0" u="none" strike="noStrike" kern="1200" cap="none" spc="0" normalizeH="0" baseline="0" noProof="0" dirty="0">
+            <a:endParaRPr kumimoji="0" lang="fr-CH" sz="1000" b="0" i="0" u="none" strike="noStrike" kern="1200" cap="none" spc="0" normalizeH="0" baseline="0" noProof="0">
               <a:ln>
                 <a:noFill/>
               </a:ln>
@@ -8119,23 +8053,6 @@
               </a:rPr>
               <a:t>1. Demo course</a:t>
             </a:r>
-            <a:endParaRPr kumimoji="0" lang="fr-FR" sz="1000" b="0" i="0" u="none" strike="noStrike" kern="1200" cap="none" spc="0" normalizeH="0" baseline="0" noProof="0" dirty="0">
-              <a:ln>
-                <a:noFill/>
-              </a:ln>
-              <a:solidFill>
-                <a:prstClr val="black">
-                  <a:lumMod val="65000"/>
-                  <a:lumOff val="35000"/>
-                </a:prstClr>
-              </a:solidFill>
-              <a:effectLst/>
-              <a:uLnTx/>
-              <a:uFillTx/>
-              <a:latin typeface="Open Sans Light" panose="020B0306030504020204" pitchFamily="34" charset="0"/>
-              <a:ea typeface="Open Sans Light" panose="020B0306030504020204" pitchFamily="34" charset="0"/>
-              <a:cs typeface="Open Sans Light" panose="020B0306030504020204" pitchFamily="34" charset="0"/>
-            </a:endParaRPr>
           </a:p>
         </p:txBody>
       </p:sp>
@@ -8323,10 +8240,10 @@
           <a:lstStyle/>
           <a:p>
             <a:r>
-              <a:rPr lang="fr-FR" dirty="0"/>
+              <a:rPr lang="fr-FR"/>
               <a:t>Cliquez pour modifier le style du titre</a:t>
             </a:r>
-            <a:endParaRPr lang="fr-CH" dirty="0"/>
+            <a:endParaRPr lang="fr-CH"/>
           </a:p>
         </p:txBody>
       </p:sp>
@@ -8357,38 +8274,38 @@
           <a:p>
             <a:pPr lvl="0"/>
             <a:r>
-              <a:rPr lang="fr-FR" dirty="0"/>
+              <a:rPr lang="fr-FR"/>
               <a:t>Cliquez pour modifier les styles du texte du masque</a:t>
             </a:r>
           </a:p>
           <a:p>
             <a:pPr lvl="1"/>
             <a:r>
-              <a:rPr lang="fr-FR" dirty="0"/>
+              <a:rPr lang="fr-FR"/>
               <a:t>Deuxième niveau</a:t>
             </a:r>
           </a:p>
           <a:p>
             <a:pPr lvl="2"/>
             <a:r>
-              <a:rPr lang="fr-FR" dirty="0"/>
+              <a:rPr lang="fr-FR"/>
               <a:t>Troisième niveau</a:t>
             </a:r>
           </a:p>
           <a:p>
             <a:pPr lvl="3"/>
             <a:r>
-              <a:rPr lang="fr-FR" dirty="0"/>
+              <a:rPr lang="fr-FR"/>
               <a:t>Quatrième niveau</a:t>
             </a:r>
           </a:p>
           <a:p>
             <a:pPr lvl="4"/>
             <a:r>
-              <a:rPr lang="fr-FR" dirty="0"/>
+              <a:rPr lang="fr-FR"/>
               <a:t>Cinquième niveau</a:t>
             </a:r>
-            <a:endParaRPr lang="fr-CH" dirty="0"/>
+            <a:endParaRPr lang="fr-CH"/>
           </a:p>
         </p:txBody>
       </p:sp>
@@ -8466,7 +8383,7 @@
               </a:rPr>
               <a:t>Dr P.-A. Mudry</a:t>
             </a:r>
-            <a:endParaRPr kumimoji="0" lang="fr-CH" sz="1000" b="0" i="0" u="none" strike="noStrike" kern="1200" cap="none" spc="0" normalizeH="0" baseline="0" noProof="0" dirty="0">
+            <a:endParaRPr kumimoji="0" lang="fr-CH" sz="1000" b="0" i="0" u="none" strike="noStrike" kern="1200" cap="none" spc="0" normalizeH="0" baseline="0" noProof="0">
               <a:ln>
                 <a:noFill/>
               </a:ln>
@@ -8560,23 +8477,6 @@
               </a:rPr>
               <a:t>1. Demo course</a:t>
             </a:r>
-            <a:endParaRPr kumimoji="0" lang="fr-FR" sz="1000" b="0" i="0" u="none" strike="noStrike" kern="1200" cap="none" spc="0" normalizeH="0" baseline="0" noProof="0" dirty="0">
-              <a:ln>
-                <a:noFill/>
-              </a:ln>
-              <a:solidFill>
-                <a:prstClr val="black">
-                  <a:lumMod val="65000"/>
-                  <a:lumOff val="35000"/>
-                </a:prstClr>
-              </a:solidFill>
-              <a:effectLst/>
-              <a:uLnTx/>
-              <a:uFillTx/>
-              <a:latin typeface="Open Sans Light" panose="020B0306030504020204" pitchFamily="34" charset="0"/>
-              <a:ea typeface="Open Sans Light" panose="020B0306030504020204" pitchFamily="34" charset="0"/>
-              <a:cs typeface="Open Sans Light" panose="020B0306030504020204" pitchFamily="34" charset="0"/>
-            </a:endParaRPr>
           </a:p>
         </p:txBody>
       </p:sp>
@@ -9047,12 +8947,12 @@
           <a:lstStyle/>
           <a:p>
             <a:r>
-              <a:rPr lang="fr-FR" sz="5400" b="0" i="0" u="none" strike="noStrike" baseline="0" dirty="0">
+              <a:rPr lang="fr-FR" sz="5400" b="0" i="0" u="none" strike="noStrike" baseline="0">
                 <a:latin typeface="SourceSansPro-Regular"/>
               </a:rPr>
               <a:t>Etude sur l’utilisation des médicaments</a:t>
             </a:r>
-            <a:endParaRPr lang="fr-CH" sz="5400" dirty="0">
+            <a:endParaRPr lang="fr-CH" sz="5400">
               <a:solidFill>
                 <a:schemeClr val="tx1">
                   <a:lumMod val="65000"/>
@@ -9299,22 +9199,26 @@
               <a:buNone/>
             </a:pPr>
             <a:r>
-              <a:rPr lang="fr-CH" sz="2400" b="1" i="1" u="sng" dirty="0"/>
-              <a:t>Maroua Zanad, Lucas Henry, </a:t>
-            </a:r>
-            <a:r>
-              <a:rPr lang="fr-CH" sz="2400" b="1" i="1" u="sng" dirty="0" err="1"/>
+              <a:rPr lang="fr-CH" sz="2400" b="1" i="1" u="sng"/>
+              <a:t>Maroua Zanad, </a:t>
+            </a:r>
+            <a:r>
+              <a:rPr lang="fr-CH" sz="2400"/>
+              <a:t>Lucas Henry, </a:t>
+            </a:r>
+            <a:r>
+              <a:rPr lang="fr-CH" sz="2400" err="1"/>
               <a:t>Vadym</a:t>
             </a:r>
             <a:r>
-              <a:rPr lang="fr-CH" sz="2400" b="1" i="1" u="sng" dirty="0"/>
+              <a:rPr lang="fr-CH" sz="2400"/>
               <a:t> </a:t>
             </a:r>
             <a:r>
-              <a:rPr lang="fr-CH" sz="2400" b="1" i="1" u="sng" dirty="0" err="1"/>
+              <a:rPr lang="fr-CH" sz="2400" err="1"/>
               <a:t>Chobu</a:t>
             </a:r>
-            <a:endParaRPr lang="fr-CH" sz="2400" i="1" dirty="0"/>
+            <a:endParaRPr lang="fr-CH" sz="2400"/>
           </a:p>
         </p:txBody>
       </p:sp>
@@ -9328,11 +9232,11 @@
   <p:clrMapOvr>
     <a:masterClrMapping/>
   </p:clrMapOvr>
-  <mc:AlternateContent xmlns:mc="http://schemas.openxmlformats.org/markup-compatibility/2006" xmlns:p14="http://schemas.microsoft.com/office/powerpoint/2010/main">
-    <mc:Choice Requires="p14">
+  <mc:AlternateContent xmlns:mc="http://schemas.openxmlformats.org/markup-compatibility/2006">
+    <mc:Choice xmlns:p14="http://schemas.microsoft.com/office/powerpoint/2010/main" Requires="p14">
       <p:transition p14:dur="0" advTm="17360"/>
     </mc:Choice>
-    <mc:Fallback xmlns="">
+    <mc:Fallback>
       <p:transition advTm="17360"/>
     </mc:Fallback>
   </mc:AlternateContent>
@@ -9384,18 +9288,10 @@
           <a:lstStyle/>
           <a:p>
             <a:r>
-              <a:rPr lang="fr-CH" dirty="0"/>
-              <a:t>Présentation du projet </a:t>
-            </a:r>
-            <a:r>
-              <a:rPr lang="fr-CH" dirty="0">
-                <a:solidFill>
-                  <a:srgbClr val="FF0000"/>
-                </a:solidFill>
-              </a:rPr>
-              <a:t>(2 minutes)</a:t>
-            </a:r>
-            <a:endParaRPr lang="en-US" dirty="0">
+              <a:rPr lang="fr-CH"/>
+              <a:t>Présentation du projet</a:t>
+            </a:r>
+            <a:endParaRPr lang="en-US">
               <a:solidFill>
                 <a:srgbClr val="FF0000"/>
               </a:solidFill>
@@ -9440,9 +9336,24 @@
               <a:buChar char="•"/>
             </a:pPr>
             <a:r>
-              <a:rPr lang="fr-CH" sz="2400" b="1" dirty="0"/>
+              <a:rPr lang="fr-CH" sz="2400" b="1"/>
               <a:t>Contexte et problématique</a:t>
             </a:r>
+          </a:p>
+          <a:p>
+            <a:pPr lvl="1">
+              <a:buClr>
+                <a:schemeClr val="accent2"/>
+              </a:buClr>
+              <a:buSzPct val="100000"/>
+              <a:buFont typeface="Arial" panose="020B0604020202020204" pitchFamily="34" charset="0"/>
+              <a:buChar char="•"/>
+            </a:pPr>
+            <a:r>
+              <a:rPr lang="fr-CH" sz="2000" b="1"/>
+              <a:t>La santé publique suisse évolue régulièrement, tant sur les causes de décès et la consommation de médicaments</a:t>
+            </a:r>
+            <a:endParaRPr lang="fr-CH" sz="2400" b="1"/>
           </a:p>
           <a:p>
             <a:pPr>
@@ -9453,7 +9364,38 @@
               <a:buFont typeface="Arial" panose="020B0604020202020204" pitchFamily="34" charset="0"/>
               <a:buChar char="•"/>
             </a:pPr>
-            <a:endParaRPr lang="fr-CH" sz="2400" b="1" dirty="0"/>
+            <a:r>
+              <a:rPr lang="fr-CH" sz="2400" b="1"/>
+              <a:t>Objectif(s)</a:t>
+            </a:r>
+          </a:p>
+          <a:p>
+            <a:pPr lvl="1">
+              <a:buClr>
+                <a:schemeClr val="accent2"/>
+              </a:buClr>
+              <a:buSzPct val="100000"/>
+              <a:buFont typeface="Arial" panose="020B0604020202020204" pitchFamily="34" charset="0"/>
+              <a:buChar char="•"/>
+            </a:pPr>
+            <a:r>
+              <a:rPr lang="fr-CH" sz="2000" b="1"/>
+              <a:t>Analyser les principales causes de décès</a:t>
+            </a:r>
+          </a:p>
+          <a:p>
+            <a:pPr lvl="1">
+              <a:buClr>
+                <a:schemeClr val="accent2"/>
+              </a:buClr>
+              <a:buSzPct val="100000"/>
+              <a:buFont typeface="Arial" panose="020B0604020202020204" pitchFamily="34" charset="0"/>
+              <a:buChar char="•"/>
+            </a:pPr>
+            <a:r>
+              <a:rPr lang="fr-CH" sz="2000" b="1"/>
+              <a:t>Etudier l’évolution de la répartition des médicaments</a:t>
+            </a:r>
           </a:p>
           <a:p>
             <a:pPr>
@@ -9465,35 +9407,9 @@
               <a:buChar char="•"/>
             </a:pPr>
             <a:r>
-              <a:rPr lang="fr-CH" sz="2400" b="1" dirty="0"/>
-              <a:t>Objectif(s)</a:t>
-            </a:r>
-          </a:p>
-          <a:p>
-            <a:pPr>
-              <a:buClr>
-                <a:schemeClr val="accent2"/>
-              </a:buClr>
-              <a:buSzPct val="100000"/>
-              <a:buFont typeface="Arial" panose="020B0604020202020204" pitchFamily="34" charset="0"/>
-              <a:buChar char="•"/>
-            </a:pPr>
-            <a:endParaRPr lang="fr-CH" sz="2400" b="1" dirty="0"/>
-          </a:p>
-          <a:p>
-            <a:pPr>
-              <a:buClr>
-                <a:schemeClr val="accent2"/>
-              </a:buClr>
-              <a:buSzPct val="100000"/>
-              <a:buFont typeface="Arial" panose="020B0604020202020204" pitchFamily="34" charset="0"/>
-              <a:buChar char="•"/>
-            </a:pPr>
-            <a:r>
-              <a:rPr lang="fr-CH" sz="2400" b="1" dirty="0"/>
+              <a:rPr lang="fr-CH" sz="2400" b="1"/>
               <a:t>Méthodes</a:t>
             </a:r>
-            <a:endParaRPr lang="fr-CH" sz="2000" b="1" dirty="0"/>
           </a:p>
         </p:txBody>
       </p:sp>
@@ -9729,7 +9645,7 @@
               <a:defRPr/>
             </a:pPr>
             <a:r>
-              <a:rPr lang="fr-CH" sz="1000" dirty="0" err="1">
+              <a:rPr lang="fr-CH" sz="1000" err="1">
                 <a:solidFill>
                   <a:prstClr val="black">
                     <a:lumMod val="65000"/>
@@ -9742,7 +9658,7 @@
               </a:rPr>
               <a:t>ProbStatIT</a:t>
             </a:r>
-            <a:endParaRPr lang="fr-CH" sz="1000" dirty="0">
+            <a:endParaRPr lang="fr-CH" sz="1000">
               <a:solidFill>
                 <a:prstClr val="black">
                   <a:lumMod val="65000"/>
@@ -9766,11 +9682,11 @@
   <p:clrMapOvr>
     <a:masterClrMapping/>
   </p:clrMapOvr>
-  <mc:AlternateContent xmlns:mc="http://schemas.openxmlformats.org/markup-compatibility/2006" xmlns:p14="http://schemas.microsoft.com/office/powerpoint/2010/main">
-    <mc:Choice Requires="p14">
+  <mc:AlternateContent xmlns:mc="http://schemas.openxmlformats.org/markup-compatibility/2006">
+    <mc:Choice xmlns:p14="http://schemas.microsoft.com/office/powerpoint/2010/main" Requires="p14">
       <p:transition p14:dur="0"/>
     </mc:Choice>
-    <mc:Fallback xmlns="">
+    <mc:Fallback>
       <p:transition/>
     </mc:Fallback>
   </mc:AlternateContent>
@@ -9822,18 +9738,18 @@
           <a:lstStyle/>
           <a:p>
             <a:r>
-              <a:rPr lang="fr-CH" dirty="0"/>
+              <a:rPr lang="fr-CH"/>
               <a:t>Plan de projet </a:t>
             </a:r>
             <a:r>
-              <a:rPr lang="fr-CH" dirty="0">
+              <a:rPr lang="fr-CH">
                 <a:solidFill>
                   <a:srgbClr val="FF0000"/>
                 </a:solidFill>
               </a:rPr>
               <a:t>(2 minutes)</a:t>
             </a:r>
-            <a:endParaRPr lang="en-US" dirty="0">
+            <a:endParaRPr lang="en-US">
               <a:solidFill>
                 <a:srgbClr val="FF0000"/>
               </a:solidFill>
@@ -9878,10 +9794,152 @@
               <a:buChar char="•"/>
             </a:pPr>
             <a:r>
-              <a:rPr lang="fr-CH" sz="2400" b="1" dirty="0"/>
-              <a:t>Explications du plan de projet et de la répartition du travail dans le groupe </a:t>
-            </a:r>
-            <a:endParaRPr lang="fr-CH" sz="2000" b="1" dirty="0"/>
+              <a:rPr lang="fr-CH" sz="2400" b="1"/>
+              <a:t>Explications du plan de projet</a:t>
+            </a:r>
+          </a:p>
+          <a:p>
+            <a:pPr lvl="1">
+              <a:buClr>
+                <a:schemeClr val="accent2"/>
+              </a:buClr>
+              <a:buSzPct val="100000"/>
+              <a:buFont typeface="Arial" panose="020B0604020202020204" pitchFamily="34" charset="0"/>
+              <a:buChar char="•"/>
+            </a:pPr>
+            <a:r>
+              <a:rPr lang="fr-CH" sz="2000" b="1"/>
+              <a:t>Récolter différentes sources de données sur les médicaments et les causes de morts</a:t>
+            </a:r>
+          </a:p>
+          <a:p>
+            <a:pPr lvl="1">
+              <a:buClr>
+                <a:schemeClr val="accent2"/>
+              </a:buClr>
+              <a:buSzPct val="100000"/>
+              <a:buFont typeface="Arial" panose="020B0604020202020204" pitchFamily="34" charset="0"/>
+              <a:buChar char="•"/>
+            </a:pPr>
+            <a:r>
+              <a:rPr lang="fr-CH" sz="2000" b="1"/>
+              <a:t>Filtrer les données pour ne garder que ce qui nous </a:t>
+            </a:r>
+            <a:r>
+              <a:rPr lang="fr-CH" sz="2000" b="1" err="1"/>
+              <a:t>interesse</a:t>
+            </a:r>
+            <a:endParaRPr lang="fr-CH" sz="2000" b="1"/>
+          </a:p>
+          <a:p>
+            <a:pPr lvl="1">
+              <a:buClr>
+                <a:schemeClr val="accent2"/>
+              </a:buClr>
+              <a:buSzPct val="100000"/>
+              <a:buFont typeface="Arial" panose="020B0604020202020204" pitchFamily="34" charset="0"/>
+              <a:buChar char="•"/>
+            </a:pPr>
+            <a:r>
+              <a:rPr lang="fr-CH" sz="2000" b="1"/>
+              <a:t>Les comparer et chercher des corrélations</a:t>
+            </a:r>
+          </a:p>
+          <a:p>
+            <a:pPr>
+              <a:buClr>
+                <a:schemeClr val="accent2"/>
+              </a:buClr>
+              <a:buSzPct val="100000"/>
+              <a:buFont typeface="Arial" panose="020B0604020202020204" pitchFamily="34" charset="0"/>
+              <a:buChar char="•"/>
+            </a:pPr>
+            <a:r>
+              <a:rPr lang="fr-CH" sz="2400" b="1"/>
+              <a:t>Répartition du travail dans le groupe</a:t>
+            </a:r>
+          </a:p>
+          <a:p>
+            <a:pPr lvl="1">
+              <a:buClr>
+                <a:schemeClr val="accent2"/>
+              </a:buClr>
+              <a:buSzPct val="100000"/>
+              <a:buFont typeface="Arial" panose="020B0604020202020204" pitchFamily="34" charset="0"/>
+              <a:buChar char="•"/>
+            </a:pPr>
+            <a:r>
+              <a:rPr lang="fr-CH" sz="2000" b="1" err="1"/>
+              <a:t>Vadym</a:t>
+            </a:r>
+            <a:r>
+              <a:rPr lang="fr-CH" sz="1600" b="1"/>
+              <a:t> </a:t>
+            </a:r>
+            <a:r>
+              <a:rPr lang="fr-CH" sz="2000" b="1"/>
+              <a:t>et Maroua</a:t>
+            </a:r>
+          </a:p>
+          <a:p>
+            <a:pPr lvl="2">
+              <a:buClr>
+                <a:schemeClr val="accent2"/>
+              </a:buClr>
+              <a:buSzPct val="100000"/>
+            </a:pPr>
+            <a:r>
+              <a:rPr lang="fr-CH" sz="1600" b="1"/>
+              <a:t>Nettoyage des données</a:t>
+            </a:r>
+          </a:p>
+          <a:p>
+            <a:pPr lvl="2">
+              <a:buClr>
+                <a:schemeClr val="accent2"/>
+              </a:buClr>
+              <a:buSzPct val="100000"/>
+            </a:pPr>
+            <a:r>
+              <a:rPr lang="fr-CH" sz="1600" b="1"/>
+              <a:t>Comparaison et recherche de corrélation entre les données</a:t>
+            </a:r>
+          </a:p>
+          <a:p>
+            <a:pPr lvl="1">
+              <a:buClr>
+                <a:schemeClr val="accent2"/>
+              </a:buClr>
+              <a:buSzPct val="100000"/>
+            </a:pPr>
+            <a:r>
+              <a:rPr lang="fr-CH" sz="2000" b="1"/>
+              <a:t>Lucas</a:t>
+            </a:r>
+          </a:p>
+          <a:p>
+            <a:pPr lvl="2">
+              <a:buClr>
+                <a:schemeClr val="accent2"/>
+              </a:buClr>
+              <a:buSzPct val="100000"/>
+            </a:pPr>
+            <a:r>
+              <a:rPr lang="fr-CH" sz="1600" b="1"/>
+              <a:t>Statistiques</a:t>
+            </a:r>
+          </a:p>
+          <a:p>
+            <a:pPr lvl="2">
+              <a:buClr>
+                <a:schemeClr val="accent2"/>
+              </a:buClr>
+              <a:buSzPct val="100000"/>
+            </a:pPr>
+            <a:r>
+              <a:rPr lang="fr-CH" sz="1600" b="1"/>
+              <a:t>Préparation Oral</a:t>
+            </a:r>
           </a:p>
         </p:txBody>
       </p:sp>
@@ -10117,7 +10175,7 @@
               <a:defRPr/>
             </a:pPr>
             <a:r>
-              <a:rPr lang="fr-CH" sz="1000" dirty="0" err="1">
+              <a:rPr lang="fr-CH" sz="1000" err="1">
                 <a:solidFill>
                   <a:prstClr val="black">
                     <a:lumMod val="65000"/>
@@ -10130,7 +10188,7 @@
               </a:rPr>
               <a:t>ProbStatIT</a:t>
             </a:r>
-            <a:endParaRPr lang="fr-CH" sz="1000" dirty="0">
+            <a:endParaRPr lang="fr-CH" sz="1000">
               <a:solidFill>
                 <a:prstClr val="black">
                   <a:lumMod val="65000"/>
@@ -10154,11 +10212,11 @@
   <p:clrMapOvr>
     <a:masterClrMapping/>
   </p:clrMapOvr>
-  <mc:AlternateContent xmlns:mc="http://schemas.openxmlformats.org/markup-compatibility/2006" xmlns:p14="http://schemas.microsoft.com/office/powerpoint/2010/main">
-    <mc:Choice Requires="p14">
+  <mc:AlternateContent xmlns:mc="http://schemas.openxmlformats.org/markup-compatibility/2006">
+    <mc:Choice xmlns:p14="http://schemas.microsoft.com/office/powerpoint/2010/main" Requires="p14">
       <p:transition p14:dur="0"/>
     </mc:Choice>
-    <mc:Fallback xmlns="">
+    <mc:Fallback>
       <p:transition/>
     </mc:Fallback>
   </mc:AlternateContent>
@@ -10210,18 +10268,18 @@
           <a:lstStyle/>
           <a:p>
             <a:r>
-              <a:rPr lang="fr-CH" dirty="0"/>
+              <a:rPr lang="fr-CH"/>
               <a:t>Votre contribution </a:t>
             </a:r>
             <a:r>
-              <a:rPr lang="fr-CH" dirty="0">
+              <a:rPr lang="fr-CH">
                 <a:solidFill>
                   <a:srgbClr val="FF0000"/>
                 </a:solidFill>
               </a:rPr>
-              <a:t>(3 minutes)</a:t>
-            </a:r>
-            <a:endParaRPr lang="en-US" dirty="0">
+              <a:t>(Maroua)</a:t>
+            </a:r>
+            <a:endParaRPr lang="en-US">
               <a:solidFill>
                 <a:srgbClr val="FF0000"/>
               </a:solidFill>
@@ -10248,7 +10306,7 @@
         <p:spPr>
           <a:xfrm>
             <a:off x="497570" y="1393312"/>
-            <a:ext cx="11143046" cy="4916008"/>
+            <a:ext cx="7470638" cy="4916008"/>
           </a:xfrm>
         </p:spPr>
         <p:txBody>
@@ -10266,10 +10324,48 @@
               <a:buChar char="•"/>
             </a:pPr>
             <a:r>
-              <a:rPr lang="fr-CH" sz="2400" b="1" dirty="0"/>
-              <a:t>Explications de votre contribution sur le projet et de vos premiers résultats</a:t>
-            </a:r>
-            <a:endParaRPr lang="fr-CH" sz="2000" b="1" dirty="0"/>
+              <a:rPr lang="fr-CH" sz="2000" b="1"/>
+              <a:t>Rassemblez les données nécessaires pour la partie sur les médicaments</a:t>
+            </a:r>
+          </a:p>
+          <a:p>
+            <a:pPr>
+              <a:buClr>
+                <a:schemeClr val="accent2"/>
+              </a:buClr>
+              <a:buSzPct val="100000"/>
+              <a:buFont typeface="Arial" panose="020B0604020202020204" pitchFamily="34" charset="0"/>
+              <a:buChar char="•"/>
+            </a:pPr>
+            <a:r>
+              <a:rPr lang="fr-CH" sz="2000" b="1"/>
+              <a:t>Trier et garder que les sources intéressantes</a:t>
+            </a:r>
+          </a:p>
+          <a:p>
+            <a:pPr>
+              <a:buClr>
+                <a:schemeClr val="accent2"/>
+              </a:buClr>
+              <a:buSzPct val="100000"/>
+              <a:buFont typeface="Arial" panose="020B0604020202020204" pitchFamily="34" charset="0"/>
+              <a:buChar char="•"/>
+            </a:pPr>
+            <a:r>
+              <a:rPr lang="fr-CH" sz="2000" b="1"/>
+              <a:t>Catégoriser chaque médicament par cause de décès</a:t>
+            </a:r>
+          </a:p>
+          <a:p>
+            <a:pPr>
+              <a:buClr>
+                <a:schemeClr val="accent2"/>
+              </a:buClr>
+              <a:buSzPct val="100000"/>
+              <a:buFont typeface="Arial" panose="020B0604020202020204" pitchFamily="34" charset="0"/>
+              <a:buChar char="•"/>
+            </a:pPr>
+            <a:endParaRPr lang="fr-CH" sz="2000" b="1"/>
           </a:p>
         </p:txBody>
       </p:sp>
@@ -10505,7 +10601,7 @@
               <a:defRPr/>
             </a:pPr>
             <a:r>
-              <a:rPr lang="fr-CH" sz="1000" dirty="0" err="1">
+              <a:rPr lang="fr-CH" sz="1000" err="1">
                 <a:solidFill>
                   <a:prstClr val="black">
                     <a:lumMod val="65000"/>
@@ -10518,7 +10614,7 @@
               </a:rPr>
               <a:t>ProbStatIT</a:t>
             </a:r>
-            <a:endParaRPr lang="fr-CH" sz="1000" dirty="0">
+            <a:endParaRPr lang="fr-CH" sz="1000">
               <a:solidFill>
                 <a:prstClr val="black">
                   <a:lumMod val="65000"/>
@@ -10532,6 +10628,42 @@
           </a:p>
         </p:txBody>
       </p:sp>
+      <p:pic>
+        <p:nvPicPr>
+          <p:cNvPr id="9" name="Image 8" descr="Une image contenant texte, capture d’écran, Police&#10;&#10;Le contenu généré par l’IA peut être incorrect.">
+            <a:extLst>
+              <a:ext uri="{FF2B5EF4-FFF2-40B4-BE49-F238E27FC236}">
+                <a16:creationId xmlns:a16="http://schemas.microsoft.com/office/drawing/2014/main" id="{8EC1AF7C-75A4-C1A5-5AA5-C42728D92190}"/>
+              </a:ext>
+            </a:extLst>
+          </p:cNvPr>
+          <p:cNvPicPr>
+            <a:picLocks noChangeAspect="1"/>
+          </p:cNvPicPr>
+          <p:nvPr/>
+        </p:nvPicPr>
+        <p:blipFill>
+          <a:blip r:embed="rId3">
+            <a:extLst>
+              <a:ext uri="{28A0092B-C50C-407E-A947-70E740481C1C}">
+                <a14:useLocalDpi xmlns:a14="http://schemas.microsoft.com/office/drawing/2010/main" val="0"/>
+              </a:ext>
+            </a:extLst>
+          </a:blip>
+          <a:stretch>
+            <a:fillRect/>
+          </a:stretch>
+        </p:blipFill>
+        <p:spPr>
+          <a:xfrm>
+            <a:off x="8040216" y="101304"/>
+            <a:ext cx="3600400" cy="2867687"/>
+          </a:xfrm>
+          <a:prstGeom prst="rect">
+            <a:avLst/>
+          </a:prstGeom>
+        </p:spPr>
+      </p:pic>
     </p:spTree>
     <p:extLst>
       <p:ext uri="{BB962C8B-B14F-4D97-AF65-F5344CB8AC3E}">
@@ -10542,11 +10674,11 @@
   <p:clrMapOvr>
     <a:masterClrMapping/>
   </p:clrMapOvr>
-  <mc:AlternateContent xmlns:mc="http://schemas.openxmlformats.org/markup-compatibility/2006" xmlns:p14="http://schemas.microsoft.com/office/powerpoint/2010/main">
-    <mc:Choice Requires="p14">
+  <mc:AlternateContent xmlns:mc="http://schemas.openxmlformats.org/markup-compatibility/2006">
+    <mc:Choice xmlns:p14="http://schemas.microsoft.com/office/powerpoint/2010/main" Requires="p14">
       <p:transition p14:dur="0"/>
     </mc:Choice>
-    <mc:Fallback xmlns="">
+    <mc:Fallback>
       <p:transition/>
     </mc:Fallback>
   </mc:AlternateContent>
@@ -11482,17 +11614,6 @@
 </file>
 
 <file path=customXml/item2.xml><?xml version="1.0" encoding="utf-8"?>
-<p:properties xmlns:p="http://schemas.microsoft.com/office/2006/metadata/properties" xmlns:xsi="http://www.w3.org/2001/XMLSchema-instance" xmlns:pc="http://schemas.microsoft.com/office/infopath/2007/PartnerControls">
-  <documentManagement>
-    <lcf76f155ced4ddcb4097134ff3c332f xmlns="867800f0-a197-48df-b3d8-63ad447b0afe">
-      <Terms xmlns="http://schemas.microsoft.com/office/infopath/2007/PartnerControls"/>
-    </lcf76f155ced4ddcb4097134ff3c332f>
-    <TaxCatchAll xmlns="e7634316-75c5-4675-ae1f-8517fcbfe30d" xsi:nil="true"/>
-  </documentManagement>
-</p:properties>
-</file>
-
-<file path=customXml/item3.xml><?xml version="1.0" encoding="utf-8"?>
 <ct:contentTypeSchema xmlns:ct="http://schemas.microsoft.com/office/2006/metadata/contentType" xmlns:ma="http://schemas.microsoft.com/office/2006/metadata/properties/metaAttributes" ct:_="" ma:_="" ma:contentTypeName="Document" ma:contentTypeID="0x0101007BAE827F9E369F47BA44DF5D5B04C2CA" ma:contentTypeVersion="11" ma:contentTypeDescription="Crée un document." ma:contentTypeScope="" ma:versionID="b7d19f48c3bb3549c387cdf7aa4712b4">
   <xsd:schema xmlns:xsd="http://www.w3.org/2001/XMLSchema" xmlns:xs="http://www.w3.org/2001/XMLSchema" xmlns:p="http://schemas.microsoft.com/office/2006/metadata/properties" xmlns:ns2="e7634316-75c5-4675-ae1f-8517fcbfe30d" xmlns:ns3="867800f0-a197-48df-b3d8-63ad447b0afe" targetNamespace="http://schemas.microsoft.com/office/2006/metadata/properties" ma:root="true" ma:fieldsID="5a40304e7c366f484882961a3762423f" ns2:_="" ns3:_="">
     <xsd:import namespace="e7634316-75c5-4675-ae1f-8517fcbfe30d"/>
@@ -11703,6 +11824,17 @@
 </ct:contentTypeSchema>
 </file>
 
+<file path=customXml/item3.xml><?xml version="1.0" encoding="utf-8"?>
+<p:properties xmlns:p="http://schemas.microsoft.com/office/2006/metadata/properties" xmlns:xsi="http://www.w3.org/2001/XMLSchema-instance" xmlns:pc="http://schemas.microsoft.com/office/infopath/2007/PartnerControls">
+  <documentManagement>
+    <lcf76f155ced4ddcb4097134ff3c332f xmlns="867800f0-a197-48df-b3d8-63ad447b0afe">
+      <Terms xmlns="http://schemas.microsoft.com/office/infopath/2007/PartnerControls"/>
+    </lcf76f155ced4ddcb4097134ff3c332f>
+    <TaxCatchAll xmlns="e7634316-75c5-4675-ae1f-8517fcbfe30d" xsi:nil="true"/>
+  </documentManagement>
+</p:properties>
+</file>
+
 <file path=customXml/itemProps1.xml><?xml version="1.0" encoding="utf-8"?>
 <ds:datastoreItem xmlns:ds="http://schemas.openxmlformats.org/officeDocument/2006/customXml" ds:itemID="{D96CA7C3-5467-41A0-A6A5-CAC955E7D149}">
   <ds:schemaRefs>
@@ -11712,37 +11844,37 @@
 </file>
 
 <file path=customXml/itemProps2.xml><?xml version="1.0" encoding="utf-8"?>
-<ds:datastoreItem xmlns:ds="http://schemas.openxmlformats.org/officeDocument/2006/customXml" ds:itemID="{F759E773-22B4-4E72-98E9-9A972373B22D}">
+<ds:datastoreItem xmlns:ds="http://schemas.openxmlformats.org/officeDocument/2006/customXml" ds:itemID="{D84B9BDF-6BDA-4CDE-91C7-275064FCDB0A}">
   <ds:schemaRefs>
+    <ds:schemaRef ds:uri="867800f0-a197-48df-b3d8-63ad447b0afe"/>
+    <ds:schemaRef ds:uri="e7634316-75c5-4675-ae1f-8517fcbfe30d"/>
+    <ds:schemaRef ds:uri="http://purl.org/dc/elements/1.1/"/>
+    <ds:schemaRef ds:uri="http://purl.org/dc/terms/"/>
+    <ds:schemaRef ds:uri="http://schemas.microsoft.com/internal/obd"/>
+    <ds:schemaRef ds:uri="http://schemas.microsoft.com/office/2006/documentManagement/types"/>
+    <ds:schemaRef ds:uri="http://schemas.microsoft.com/office/2006/metadata/contentType"/>
+    <ds:schemaRef ds:uri="http://schemas.microsoft.com/office/2006/metadata/properties"/>
+    <ds:schemaRef ds:uri="http://schemas.microsoft.com/office/2006/metadata/properties/metaAttributes"/>
     <ds:schemaRef ds:uri="http://schemas.microsoft.com/office/infopath/2007/PartnerControls"/>
-    <ds:schemaRef ds:uri="http://purl.org/dc/elements/1.1/"/>
-    <ds:schemaRef ds:uri="http://schemas.microsoft.com/office/2006/documentManagement/types"/>
-    <ds:schemaRef ds:uri="867800f0-a197-48df-b3d8-63ad447b0afe"/>
-    <ds:schemaRef ds:uri="http://purl.org/dc/terms/"/>
     <ds:schemaRef ds:uri="http://schemas.openxmlformats.org/package/2006/metadata/core-properties"/>
-    <ds:schemaRef ds:uri="http://purl.org/dc/dcmitype/"/>
-    <ds:schemaRef ds:uri="e7634316-75c5-4675-ae1f-8517fcbfe30d"/>
-    <ds:schemaRef ds:uri="http://schemas.microsoft.com/office/2006/metadata/properties"/>
-    <ds:schemaRef ds:uri="http://www.w3.org/XML/1998/namespace"/>
+    <ds:schemaRef ds:uri="http://www.w3.org/2001/XMLSchema"/>
   </ds:schemaRefs>
 </ds:datastoreItem>
 </file>
 
 <file path=customXml/itemProps3.xml><?xml version="1.0" encoding="utf-8"?>
-<ds:datastoreItem xmlns:ds="http://schemas.openxmlformats.org/officeDocument/2006/customXml" ds:itemID="{D84B9BDF-6BDA-4CDE-91C7-275064FCDB0A}">
+<ds:datastoreItem xmlns:ds="http://schemas.openxmlformats.org/officeDocument/2006/customXml" ds:itemID="{F759E773-22B4-4E72-98E9-9A972373B22D}">
   <ds:schemaRefs>
-    <ds:schemaRef ds:uri="http://schemas.microsoft.com/office/2006/metadata/contentType"/>
-    <ds:schemaRef ds:uri="http://schemas.microsoft.com/office/2006/metadata/properties/metaAttributes"/>
-    <ds:schemaRef ds:uri="http://www.w3.org/2001/XMLSchema"/>
+    <ds:schemaRef ds:uri="867800f0-a197-48df-b3d8-63ad447b0afe"/>
+    <ds:schemaRef ds:uri="e7634316-75c5-4675-ae1f-8517fcbfe30d"/>
+    <ds:schemaRef ds:uri="http://purl.org/dc/dcmitype/"/>
+    <ds:schemaRef ds:uri="http://purl.org/dc/elements/1.1/"/>
+    <ds:schemaRef ds:uri="http://purl.org/dc/terms/"/>
+    <ds:schemaRef ds:uri="http://schemas.microsoft.com/office/2006/documentManagement/types"/>
     <ds:schemaRef ds:uri="http://schemas.microsoft.com/office/2006/metadata/properties"/>
-    <ds:schemaRef ds:uri="e7634316-75c5-4675-ae1f-8517fcbfe30d"/>
-    <ds:schemaRef ds:uri="867800f0-a197-48df-b3d8-63ad447b0afe"/>
-    <ds:schemaRef ds:uri="http://schemas.microsoft.com/office/2006/documentManagement/types"/>
     <ds:schemaRef ds:uri="http://schemas.microsoft.com/office/infopath/2007/PartnerControls"/>
     <ds:schemaRef ds:uri="http://schemas.openxmlformats.org/package/2006/metadata/core-properties"/>
-    <ds:schemaRef ds:uri="http://purl.org/dc/elements/1.1/"/>
-    <ds:schemaRef ds:uri="http://purl.org/dc/terms/"/>
-    <ds:schemaRef ds:uri="http://schemas.microsoft.com/internal/obd"/>
+    <ds:schemaRef ds:uri="http://www.w3.org/XML/1998/namespace"/>
   </ds:schemaRefs>
 </ds:datastoreItem>
 </file>
</xml_diff>